<commit_message>
fix: update documentation and session deck generation script to clarify device trust limitations and recommended accommodations
</commit_message>
<xml_diff>
--- a/docs/deck/croesus-session-deck.pptx
+++ b/docs/deck/croesus-session-deck.pptx
@@ -655,7 +655,7 @@
           <a:lstStyle/>
           <a:p>
             <a:r>
-              <a:t>The point: every branch has a small, reversible fix. Nobody needs a re-architecture, and Desjardins does not need to weaken CA.</a:t>
+              <a:t>The point: every branch has a small, reversible fix. Nobody needs a re-architecture, and Desjardins does not need to weaken CA. On device trust — credit Mathieu Santerre for the correction: the inbound trust settings honour a device claim carried in a guest's token from their home tenant, so they cannot bridge Prod device state into a native non-prod sign-in.</a:t>
             </a:r>
           </a:p>
         </p:txBody>
@@ -5600,7 +5600,7 @@
                 </a:solidFill>
                 <a:latin typeface="Segoe UI"/>
               </a:rPr>
-              <a:t>Prefer B2B ‘Trust compliant devices’ over a broad CA exception.</a:t>
+              <a:t>Rule out device trust as the lever.</a:t>
             </a:r>
             <a:r>
               <a:rPr sz="1700" b="0">
@@ -5609,7 +5609,7 @@
                 </a:solidFill>
                 <a:latin typeface="Segoe UI"/>
               </a:rPr>
-              <a:t> It preserves the device-compliance signal instead of discarding it.</a:t>
+              <a:t> Cross-tenant ‘Trust compliant devices’ only fires on a B2B guest sign-in, and the blocked leg is a server-side call with no device context at all.</a:t>
             </a:r>
           </a:p>
           <a:p>

</xml_diff>